<commit_message>
Apresentações: imagens recortadas na proporção exata, sem distorção
Co-Authored-By: Claude Fable 5.1 <noreply@anthropic.com>
Claude-Session: https://claude.ai/code/session_019UKDqx9VshcyuwTFbJxj3E
</commit_message>
<xml_diff>
--- a/apresentacoes/Reducao-de-Perdas-de-Agua-NorteSul.pptx
+++ b/apresentacoes/Reducao-de-Perdas-de-Agua-NorteSul.pptx
@@ -2979,7 +2979,7 @@
       </p:sp>
       <p:pic>
         <p:nvPicPr>
-          <p:cNvPr id="3" name="Image 0" descr="/tmp/claude-0/-home-user-norte-sul-portfolio/b828416d-028b-56b8-943d-a9bc67fc20c3/scratchpad/pptx_out/p_capa.jpg">    </p:cNvPr>
+          <p:cNvPr id="3" name="Image 0" descr="/tmp/claude-0/-home-user-norte-sul-portfolio/b828416d-028b-56b8-943d-a9bc67fc20c3/scratchpad/pptx_out/cropped/p_capa_4.8x5.4.jpg">    </p:cNvPr>
           <p:cNvPicPr>
             <a:picLocks noChangeAspect="1"/>
           </p:cNvPicPr>
@@ -2987,8 +2987,9 @@
         </p:nvPicPr>
         <p:blipFill>
           <a:blip r:embed="rId2"/>
-          <a:srcRect l="0" r="0" t="0" b="0"/>
-          <a:stretch/>
+          <a:stretch>
+            <a:fillRect/>
+          </a:stretch>
         </p:blipFill>
         <p:spPr>
           <a:xfrm>
@@ -3143,8 +3144,9 @@
         </p:nvPicPr>
         <p:blipFill>
           <a:blip r:embed="rId3"/>
-          <a:srcRect l="0" r="0" t="0" b="0"/>
-          <a:stretch/>
+          <a:stretch>
+            <a:fillRect/>
+          </a:stretch>
         </p:blipFill>
         <p:spPr>
           <a:xfrm>
@@ -3189,13 +3191,14 @@
         </p:nvPicPr>
         <p:blipFill>
           <a:blip r:embed="rId4"/>
-          <a:srcRect l="0" r="0" t="0" b="0"/>
-          <a:stretch/>
+          <a:stretch>
+            <a:fillRect/>
+          </a:stretch>
         </p:blipFill>
         <p:spPr>
           <a:xfrm>
             <a:off x="1325880" y="6382512"/>
-            <a:ext cx="640080" cy="384048"/>
+            <a:ext cx="610819" cy="384048"/>
           </a:xfrm>
           <a:prstGeom prst="rect">
             <a:avLst/>
@@ -3391,8 +3394,9 @@
         </p:nvPicPr>
         <p:blipFill>
           <a:blip r:embed="rId1"/>
-          <a:srcRect l="0" r="0" t="0" b="0"/>
-          <a:stretch/>
+          <a:stretch>
+            <a:fillRect/>
+          </a:stretch>
         </p:blipFill>
         <p:spPr>
           <a:xfrm>
@@ -3437,13 +3441,14 @@
         </p:nvPicPr>
         <p:blipFill>
           <a:blip r:embed="rId2"/>
-          <a:srcRect l="0" r="0" t="0" b="0"/>
-          <a:stretch/>
+          <a:stretch>
+            <a:fillRect/>
+          </a:stretch>
         </p:blipFill>
         <p:spPr>
           <a:xfrm>
             <a:off x="1325880" y="6382512"/>
-            <a:ext cx="640080" cy="384048"/>
+            <a:ext cx="610819" cy="384048"/>
           </a:xfrm>
           <a:prstGeom prst="rect">
             <a:avLst/>
@@ -4372,8 +4377,9 @@
         </p:nvPicPr>
         <p:blipFill>
           <a:blip r:embed="rId1"/>
-          <a:srcRect l="0" r="0" t="0" b="0"/>
-          <a:stretch/>
+          <a:stretch>
+            <a:fillRect/>
+          </a:stretch>
         </p:blipFill>
         <p:spPr>
           <a:xfrm>
@@ -4418,13 +4424,14 @@
         </p:nvPicPr>
         <p:blipFill>
           <a:blip r:embed="rId2"/>
-          <a:srcRect l="0" r="0" t="0" b="0"/>
-          <a:stretch/>
+          <a:stretch>
+            <a:fillRect/>
+          </a:stretch>
         </p:blipFill>
         <p:spPr>
           <a:xfrm>
             <a:off x="1325880" y="6382512"/>
-            <a:ext cx="640080" cy="384048"/>
+            <a:ext cx="610819" cy="384048"/>
           </a:xfrm>
           <a:prstGeom prst="rect">
             <a:avLst/>
@@ -4620,8 +4627,9 @@
         </p:nvPicPr>
         <p:blipFill>
           <a:blip r:embed="rId1"/>
-          <a:srcRect l="0" r="0" t="0" b="0"/>
-          <a:stretch/>
+          <a:stretch>
+            <a:fillRect/>
+          </a:stretch>
         </p:blipFill>
         <p:spPr>
           <a:xfrm>
@@ -4666,13 +4674,14 @@
         </p:nvPicPr>
         <p:blipFill>
           <a:blip r:embed="rId2"/>
-          <a:srcRect l="0" r="0" t="0" b="0"/>
-          <a:stretch/>
+          <a:stretch>
+            <a:fillRect/>
+          </a:stretch>
         </p:blipFill>
         <p:spPr>
           <a:xfrm>
             <a:off x="1325880" y="6382512"/>
-            <a:ext cx="640080" cy="384048"/>
+            <a:ext cx="610819" cy="384048"/>
           </a:xfrm>
           <a:prstGeom prst="rect">
             <a:avLst/>
@@ -5723,8 +5732,9 @@
         </p:nvPicPr>
         <p:blipFill>
           <a:blip r:embed="rId2"/>
-          <a:srcRect l="0" r="0" t="0" b="0"/>
-          <a:stretch/>
+          <a:stretch>
+            <a:fillRect/>
+          </a:stretch>
         </p:blipFill>
         <p:spPr>
           <a:xfrm>
@@ -5769,13 +5779,14 @@
         </p:nvPicPr>
         <p:blipFill>
           <a:blip r:embed="rId3"/>
-          <a:srcRect l="0" r="0" t="0" b="0"/>
-          <a:stretch/>
+          <a:stretch>
+            <a:fillRect/>
+          </a:stretch>
         </p:blipFill>
         <p:spPr>
           <a:xfrm>
             <a:off x="1325880" y="6382512"/>
-            <a:ext cx="640080" cy="384048"/>
+            <a:ext cx="610819" cy="384048"/>
           </a:xfrm>
           <a:prstGeom prst="rect">
             <a:avLst/>
@@ -6572,8 +6583,9 @@
         </p:nvPicPr>
         <p:blipFill>
           <a:blip r:embed="rId1"/>
-          <a:srcRect l="0" r="0" t="0" b="0"/>
-          <a:stretch/>
+          <a:stretch>
+            <a:fillRect/>
+          </a:stretch>
         </p:blipFill>
         <p:spPr>
           <a:xfrm>
@@ -6618,13 +6630,14 @@
         </p:nvPicPr>
         <p:blipFill>
           <a:blip r:embed="rId2"/>
-          <a:srcRect l="0" r="0" t="0" b="0"/>
-          <a:stretch/>
+          <a:stretch>
+            <a:fillRect/>
+          </a:stretch>
         </p:blipFill>
         <p:spPr>
           <a:xfrm>
             <a:off x="1325880" y="6382512"/>
-            <a:ext cx="640080" cy="384048"/>
+            <a:ext cx="610819" cy="384048"/>
           </a:xfrm>
           <a:prstGeom prst="rect">
             <a:avLst/>
@@ -7235,8 +7248,9 @@
         </p:nvPicPr>
         <p:blipFill>
           <a:blip r:embed="rId2"/>
-          <a:srcRect l="0" r="0" t="0" b="0"/>
-          <a:stretch/>
+          <a:stretch>
+            <a:fillRect/>
+          </a:stretch>
         </p:blipFill>
         <p:spPr>
           <a:xfrm>
@@ -7281,13 +7295,14 @@
         </p:nvPicPr>
         <p:blipFill>
           <a:blip r:embed="rId3"/>
-          <a:srcRect l="0" r="0" t="0" b="0"/>
-          <a:stretch/>
+          <a:stretch>
+            <a:fillRect/>
+          </a:stretch>
         </p:blipFill>
         <p:spPr>
           <a:xfrm>
             <a:off x="1325880" y="6382512"/>
-            <a:ext cx="640080" cy="384048"/>
+            <a:ext cx="610819" cy="384048"/>
           </a:xfrm>
           <a:prstGeom prst="rect">
             <a:avLst/>
@@ -7380,7 +7395,7 @@
       </p:sp>
       <p:pic>
         <p:nvPicPr>
-          <p:cNvPr id="10" name="Image 2" descr="/tmp/claude-0/-home-user-norte-sul-portfolio/b828416d-028b-56b8-943d-a9bc67fc20c3/scratchpad/pptx_out/p_copos.jpg">    </p:cNvPr>
+          <p:cNvPr id="10" name="Image 2" descr="/tmp/claude-0/-home-user-norte-sul-portfolio/b828416d-028b-56b8-943d-a9bc67fc20c3/scratchpad/pptx_out/cropped/p_copos_5.44x4.12.jpg">    </p:cNvPr>
           <p:cNvPicPr>
             <a:picLocks noChangeAspect="1"/>
           </p:cNvPicPr>
@@ -7388,8 +7403,9 @@
         </p:nvPicPr>
         <p:blipFill>
           <a:blip r:embed="rId4"/>
-          <a:srcRect l="0" r="0" t="0" b="0"/>
-          <a:stretch/>
+          <a:stretch>
+            <a:fillRect/>
+          </a:stretch>
         </p:blipFill>
         <p:spPr>
           <a:xfrm>
@@ -7837,8 +7853,9 @@
         </p:nvPicPr>
         <p:blipFill>
           <a:blip r:embed="rId1"/>
-          <a:srcRect l="0" r="0" t="0" b="0"/>
-          <a:stretch/>
+          <a:stretch>
+            <a:fillRect/>
+          </a:stretch>
         </p:blipFill>
         <p:spPr>
           <a:xfrm>
@@ -7883,13 +7900,14 @@
         </p:nvPicPr>
         <p:blipFill>
           <a:blip r:embed="rId2"/>
-          <a:srcRect l="0" r="0" t="0" b="0"/>
-          <a:stretch/>
+          <a:stretch>
+            <a:fillRect/>
+          </a:stretch>
         </p:blipFill>
         <p:spPr>
           <a:xfrm>
             <a:off x="1325880" y="6382512"/>
-            <a:ext cx="640080" cy="384048"/>
+            <a:ext cx="610819" cy="384048"/>
           </a:xfrm>
           <a:prstGeom prst="rect">
             <a:avLst/>
@@ -8650,8 +8668,9 @@
         </p:nvPicPr>
         <p:blipFill>
           <a:blip r:embed="rId2"/>
-          <a:srcRect l="0" r="0" t="0" b="0"/>
-          <a:stretch/>
+          <a:stretch>
+            <a:fillRect/>
+          </a:stretch>
         </p:blipFill>
         <p:spPr>
           <a:xfrm>
@@ -8696,13 +8715,14 @@
         </p:nvPicPr>
         <p:blipFill>
           <a:blip r:embed="rId3"/>
-          <a:srcRect l="0" r="0" t="0" b="0"/>
-          <a:stretch/>
+          <a:stretch>
+            <a:fillRect/>
+          </a:stretch>
         </p:blipFill>
         <p:spPr>
           <a:xfrm>
             <a:off x="1325880" y="6382512"/>
-            <a:ext cx="640080" cy="384048"/>
+            <a:ext cx="610819" cy="384048"/>
           </a:xfrm>
           <a:prstGeom prst="rect">
             <a:avLst/>
@@ -9266,8 +9286,9 @@
         </p:nvPicPr>
         <p:blipFill>
           <a:blip r:embed="rId1"/>
-          <a:srcRect l="0" r="0" t="0" b="0"/>
-          <a:stretch/>
+          <a:stretch>
+            <a:fillRect/>
+          </a:stretch>
         </p:blipFill>
         <p:spPr>
           <a:xfrm>
@@ -9312,13 +9333,14 @@
         </p:nvPicPr>
         <p:blipFill>
           <a:blip r:embed="rId2"/>
-          <a:srcRect l="0" r="0" t="0" b="0"/>
-          <a:stretch/>
+          <a:stretch>
+            <a:fillRect/>
+          </a:stretch>
         </p:blipFill>
         <p:spPr>
           <a:xfrm>
             <a:off x="1325880" y="6382512"/>
-            <a:ext cx="640080" cy="384048"/>
+            <a:ext cx="610819" cy="384048"/>
           </a:xfrm>
           <a:prstGeom prst="rect">
             <a:avLst/>
@@ -9798,8 +9820,9 @@
         </p:nvPicPr>
         <p:blipFill>
           <a:blip r:embed="rId1"/>
-          <a:srcRect l="0" r="0" t="0" b="0"/>
-          <a:stretch/>
+          <a:stretch>
+            <a:fillRect/>
+          </a:stretch>
         </p:blipFill>
         <p:spPr>
           <a:xfrm>
@@ -9844,13 +9867,14 @@
         </p:nvPicPr>
         <p:blipFill>
           <a:blip r:embed="rId2"/>
-          <a:srcRect l="0" r="0" t="0" b="0"/>
-          <a:stretch/>
+          <a:stretch>
+            <a:fillRect/>
+          </a:stretch>
         </p:blipFill>
         <p:spPr>
           <a:xfrm>
             <a:off x="1325880" y="6382512"/>
-            <a:ext cx="640080" cy="384048"/>
+            <a:ext cx="610819" cy="384048"/>
           </a:xfrm>
           <a:prstGeom prst="rect">
             <a:avLst/>

</xml_diff>

<commit_message>
Apresentações: ilustração da equipe no slide de agradecimento
Co-Authored-By: Claude Fable 5.1 <noreply@anthropic.com>
Claude-Session: https://claude.ai/code/session_019UKDqx9VshcyuwTFbJxj3E
</commit_message>
<xml_diff>
--- a/apresentacoes/Reducao-de-Perdas-de-Agua-NorteSul.pptx
+++ b/apresentacoes/Reducao-de-Perdas-de-Agua-NorteSul.pptx
@@ -4306,9 +4306,33 @@
           </a:p>
         </p:txBody>
       </p:sp>
-      <p:sp>
-        <p:nvSpPr>
-          <p:cNvPr id="5" name="Text 3"/>
+      <p:pic>
+        <p:nvPicPr>
+          <p:cNvPr id="5" name="Image 0" descr="/tmp/claude-0/-home-user-norte-sul-portfolio/b828416d-028b-56b8-943d-a9bc67fc20c3/scratchpad/pptx_out/equipe_navy.png">    </p:cNvPr>
+          <p:cNvPicPr>
+            <a:picLocks noChangeAspect="1"/>
+          </p:cNvPicPr>
+          <p:nvPr/>
+        </p:nvPicPr>
+        <p:blipFill>
+          <a:blip r:embed="rId1"/>
+          <a:stretch>
+            <a:fillRect/>
+          </a:stretch>
+        </p:blipFill>
+        <p:spPr>
+          <a:xfrm>
+            <a:off x="6933458" y="1051560"/>
+            <a:ext cx="4618157" cy="4206240"/>
+          </a:xfrm>
+          <a:prstGeom prst="rect">
+            <a:avLst/>
+          </a:prstGeom>
+        </p:spPr>
+      </p:pic>
+      <p:sp>
+        <p:nvSpPr>
+          <p:cNvPr id="6" name="Text 3"/>
           <p:cNvSpPr txBox="1"/>
           <p:nvPr/>
         </p:nvSpPr>
@@ -4344,7 +4368,7 @@
       </p:sp>
       <p:sp>
         <p:nvSpPr>
-          <p:cNvPr id="6" name="Shape 4"/>
+          <p:cNvPr id="7" name="Shape 4"/>
           <p:cNvSpPr/>
           <p:nvPr/>
         </p:nvSpPr>
@@ -4369,54 +4393,7 @@
       </p:sp>
       <p:pic>
         <p:nvPicPr>
-          <p:cNvPr id="7" name="Image 0" descr="/tmp/claude-0/-home-user-norte-sul-portfolio/b828416d-028b-56b8-943d-a9bc67fc20c3/scratchpad/pptx_out/logo_met.png">    </p:cNvPr>
-          <p:cNvPicPr>
-            <a:picLocks noChangeAspect="1"/>
-          </p:cNvPicPr>
-          <p:nvPr/>
-        </p:nvPicPr>
-        <p:blipFill>
-          <a:blip r:embed="rId1"/>
-          <a:stretch>
-            <a:fillRect/>
-          </a:stretch>
-        </p:blipFill>
-        <p:spPr>
-          <a:xfrm>
-            <a:off x="502920" y="6382512"/>
-            <a:ext cx="548640" cy="384048"/>
-          </a:xfrm>
-          <a:prstGeom prst="rect">
-            <a:avLst/>
-          </a:prstGeom>
-        </p:spPr>
-      </p:pic>
-      <p:sp>
-        <p:nvSpPr>
-          <p:cNvPr id="8" name="Shape 5"/>
-          <p:cNvSpPr/>
-          <p:nvPr/>
-        </p:nvSpPr>
-        <p:spPr>
-          <a:xfrm>
-            <a:off x="1188720" y="6419088"/>
-            <a:ext cx="0" cy="310896"/>
-          </a:xfrm>
-          <a:prstGeom prst="line">
-            <a:avLst/>
-          </a:prstGeom>
-          <a:noFill/>
-          <a:ln w="9525">
-            <a:solidFill>
-              <a:srgbClr val="C9D6EA"/>
-            </a:solidFill>
-            <a:prstDash val="solid"/>
-          </a:ln>
-        </p:spPr>
-      </p:sp>
-      <p:pic>
-        <p:nvPicPr>
-          <p:cNvPr id="9" name="Image 1" descr="/tmp/claude-0/-home-user-norte-sul-portfolio/b828416d-028b-56b8-943d-a9bc67fc20c3/scratchpad/pptx_out/logo_ns.png">    </p:cNvPr>
+          <p:cNvPr id="8" name="Image 1" descr="/tmp/claude-0/-home-user-norte-sul-portfolio/b828416d-028b-56b8-943d-a9bc67fc20c3/scratchpad/pptx_out/logo_met.png">    </p:cNvPr>
           <p:cNvPicPr>
             <a:picLocks noChangeAspect="1"/>
           </p:cNvPicPr>
@@ -4430,6 +4407,53 @@
         </p:blipFill>
         <p:spPr>
           <a:xfrm>
+            <a:off x="502920" y="6382512"/>
+            <a:ext cx="548640" cy="384048"/>
+          </a:xfrm>
+          <a:prstGeom prst="rect">
+            <a:avLst/>
+          </a:prstGeom>
+        </p:spPr>
+      </p:pic>
+      <p:sp>
+        <p:nvSpPr>
+          <p:cNvPr id="9" name="Shape 5"/>
+          <p:cNvSpPr/>
+          <p:nvPr/>
+        </p:nvSpPr>
+        <p:spPr>
+          <a:xfrm>
+            <a:off x="1188720" y="6419088"/>
+            <a:ext cx="0" cy="310896"/>
+          </a:xfrm>
+          <a:prstGeom prst="line">
+            <a:avLst/>
+          </a:prstGeom>
+          <a:noFill/>
+          <a:ln w="9525">
+            <a:solidFill>
+              <a:srgbClr val="C9D6EA"/>
+            </a:solidFill>
+            <a:prstDash val="solid"/>
+          </a:ln>
+        </p:spPr>
+      </p:sp>
+      <p:pic>
+        <p:nvPicPr>
+          <p:cNvPr id="10" name="Image 2" descr="/tmp/claude-0/-home-user-norte-sul-portfolio/b828416d-028b-56b8-943d-a9bc67fc20c3/scratchpad/pptx_out/logo_ns.png">    </p:cNvPr>
+          <p:cNvPicPr>
+            <a:picLocks noChangeAspect="1"/>
+          </p:cNvPicPr>
+          <p:nvPr/>
+        </p:nvPicPr>
+        <p:blipFill>
+          <a:blip r:embed="rId3"/>
+          <a:stretch>
+            <a:fillRect/>
+          </a:stretch>
+        </p:blipFill>
+        <p:spPr>
+          <a:xfrm>
             <a:off x="1325880" y="6382512"/>
             <a:ext cx="610819" cy="384048"/>
           </a:xfrm>
@@ -4440,7 +4464,7 @@
       </p:pic>
       <p:sp>
         <p:nvSpPr>
-          <p:cNvPr id="10" name="Text 6"/>
+          <p:cNvPr id="11" name="Text 6"/>
           <p:cNvSpPr txBox="1"/>
           <p:nvPr/>
         </p:nvSpPr>

</xml_diff>

<commit_message>
Apresentações: ilustração da equipe refeita com rostos e traços completos
Co-Authored-By: Claude Fable 5.1 <noreply@anthropic.com>
Claude-Session: https://claude.ai/code/session_019UKDqx9VshcyuwTFbJxj3E
</commit_message>
<xml_diff>
--- a/apresentacoes/Reducao-de-Perdas-de-Agua-NorteSul.pptx
+++ b/apresentacoes/Reducao-de-Perdas-de-Agua-NorteSul.pptx
@@ -4322,8 +4322,8 @@
         </p:blipFill>
         <p:spPr>
           <a:xfrm>
-            <a:off x="6933458" y="1051560"/>
-            <a:ext cx="4618157" cy="4206240"/>
+            <a:off x="6373178" y="1051560"/>
+            <a:ext cx="5178437" cy="4206240"/>
           </a:xfrm>
           <a:prstGeom prst="rect">
             <a:avLst/>

</xml_diff>

<commit_message>
Apresentações: acabamento final da ilustração da equipe
Co-Authored-By: Claude Fable 5.1 <noreply@anthropic.com>
Claude-Session: https://claude.ai/code/session_019UKDqx9VshcyuwTFbJxj3E
</commit_message>
<xml_diff>
--- a/apresentacoes/Reducao-de-Perdas-de-Agua-NorteSul.pptx
+++ b/apresentacoes/Reducao-de-Perdas-de-Agua-NorteSul.pptx
@@ -4322,8 +4322,8 @@
         </p:blipFill>
         <p:spPr>
           <a:xfrm>
-            <a:off x="6373178" y="1051560"/>
-            <a:ext cx="5178437" cy="4206240"/>
+            <a:off x="6862584" y="1051560"/>
+            <a:ext cx="4689032" cy="4206240"/>
           </a:xfrm>
           <a:prstGeom prst="rect">
             <a:avLst/>

</xml_diff>

<commit_message>
Apresentações: ilustrações em linha (drenagem e rede de água) no slide final
Co-Authored-By: Claude Opus 5.5 <noreply@anthropic.com>
Claude-Session: https://claude.ai/code/session_019UKDqx9VshcyuwTFbJxj3E
</commit_message>
<xml_diff>
--- a/apresentacoes/Reducao-de-Perdas-de-Agua-NorteSul.pptx
+++ b/apresentacoes/Reducao-de-Perdas-de-Agua-NorteSul.pptx
@@ -4308,7 +4308,7 @@
       </p:sp>
       <p:pic>
         <p:nvPicPr>
-          <p:cNvPr id="5" name="Image 0" descr="/tmp/claude-0/-home-user-norte-sul-portfolio/b828416d-028b-56b8-943d-a9bc67fc20c3/scratchpad/pptx_out/equipe_navy.png">    </p:cNvPr>
+          <p:cNvPr id="5" name="Image 0" descr="/tmp/claude-0/-home-user-norte-sul-portfolio/b828416d-028b-56b8-943d-a9bc67fc20c3/scratchpad/pptx_out/ilustra_agua.png">    </p:cNvPr>
           <p:cNvPicPr>
             <a:picLocks noChangeAspect="1"/>
           </p:cNvPicPr>
@@ -4322,8 +4322,8 @@
         </p:blipFill>
         <p:spPr>
           <a:xfrm>
-            <a:off x="6862584" y="1051560"/>
-            <a:ext cx="4689032" cy="4206240"/>
+            <a:off x="6613855" y="1534482"/>
+            <a:ext cx="4937760" cy="3057515"/>
           </a:xfrm>
           <a:prstGeom prst="rect">
             <a:avLst/>

</xml_diff>

<commit_message>
Caminhão Norte Sul no slide de Obrigado das duas apresentações
Desenho original mantido inteiro, só a cor petróleo trocada pelo navy 0A3377
do Obrigado, com fundo transparente.

Co-Authored-By: Claude Opus 5.5 <noreply@anthropic.com>
Claude-Session: https://claude.ai/code/session_019UKDqx9VshcyuwTFbJxj3E
</commit_message>
<xml_diff>
--- a/apresentacoes/Reducao-de-Perdas-de-Agua-NorteSul.pptx
+++ b/apresentacoes/Reducao-de-Perdas-de-Agua-NorteSul.pptx
@@ -4308,7 +4308,7 @@
       </p:sp>
       <p:pic>
         <p:nvPicPr>
-          <p:cNvPr id="5" name="Image 0" descr="/tmp/claude-0/-home-user-norte-sul-portfolio/b828416d-028b-56b8-943d-a9bc67fc20c3/scratchpad/pptx_out/ilustra_agua.png">    </p:cNvPr>
+          <p:cNvPr id="5" name="Image 0" descr="/tmp/claude-0/-home-user-norte-sul-portfolio/b828416d-028b-56b8-943d-a9bc67fc20c3/scratchpad/pptx_out/caminhao_navy.png">    </p:cNvPr>
           <p:cNvPicPr>
             <a:picLocks noChangeAspect="1"/>
           </p:cNvPicPr>
@@ -4322,8 +4322,8 @@
         </p:blipFill>
         <p:spPr>
           <a:xfrm>
-            <a:off x="6613855" y="1534482"/>
-            <a:ext cx="4937760" cy="3057515"/>
+            <a:off x="6613855" y="1677054"/>
+            <a:ext cx="4937760" cy="2772373"/>
           </a:xfrm>
           <a:prstGeom prst="rect">
             <a:avLst/>

</xml_diff>

<commit_message>
Caminhão do Obrigado refeito a partir da versão sem fundo
Usa o recorte original enviado (transparência própria), só com a cor
petróleo trocada pelo navy 0A3377.

Co-Authored-By: Claude Opus 5.5 <noreply@anthropic.com>
Claude-Session: https://claude.ai/code/session_019UKDqx9VshcyuwTFbJxj3E
</commit_message>
<xml_diff>
--- a/apresentacoes/Reducao-de-Perdas-de-Agua-NorteSul.pptx
+++ b/apresentacoes/Reducao-de-Perdas-de-Agua-NorteSul.pptx
@@ -4322,8 +4322,8 @@
         </p:blipFill>
         <p:spPr>
           <a:xfrm>
-            <a:off x="6613855" y="1677054"/>
-            <a:ext cx="4937760" cy="2772373"/>
+            <a:off x="6613855" y="1666466"/>
+            <a:ext cx="4937760" cy="2793548"/>
           </a:xfrm>
           <a:prstGeom prst="rect">
             <a:avLst/>

</xml_diff>